<commit_message>
Update PowerPoint for song #245 in FUBC - Українські
</commit_message>
<xml_diff>
--- a/fubc-ua/245-Жити з Ісусом (Пісні Спасенних №244).pptx
+++ b/fubc-ua/245-Жити з Ісусом (Пісні Спасенних №244).pptx
@@ -1469,7 +1469,7 @@
         </p:nvSpPr>
         <p:spPr>
           <a:xfrm>
-            <a:off x="2821153" y="2755392"/>
+            <a:off x="2920213" y="2755392"/>
             <a:ext cx="0" cy="2971800"/>
           </a:xfrm>
           <a:prstGeom prst="line">
@@ -1492,7 +1492,7 @@
         </p:nvSpPr>
         <p:spPr>
           <a:xfrm>
-            <a:off x="9376943" y="2755392"/>
+            <a:off x="9277883" y="2755392"/>
             <a:ext cx="0" cy="2971800"/>
           </a:xfrm>
           <a:prstGeom prst="line">
@@ -1515,8 +1515,8 @@
         </p:nvSpPr>
         <p:spPr>
           <a:xfrm>
-            <a:off x="9509023" y="4010152"/>
-            <a:ext cx="792480" cy="462280"/>
+            <a:off x="9376943" y="3921252"/>
+            <a:ext cx="1097280" cy="640080"/>
           </a:xfrm>
           <a:prstGeom prst="rect">
             <a:avLst/>
@@ -1532,9 +1532,9 @@
               <a:buNone/>
             </a:pPr>
             <a:r>
-              <a:rPr lang="en-US" sz="2600" b="1" dirty="0">
+              <a:rPr lang="en-US" sz="3600" b="1" dirty="0">
                 <a:solidFill>
-                  <a:srgbClr val="8A8A8A"/>
+                  <a:srgbClr val="BBBBBB"/>
                 </a:solidFill>
                 <a:latin typeface="Arial" pitchFamily="34" charset="0"/>
                 <a:ea typeface="Arial" pitchFamily="34" charset="-122"/>
@@ -1542,7 +1542,7 @@
               </a:rPr>
               <a:t>×2</a:t>
             </a:r>
-            <a:endParaRPr lang="en-US" sz="2600" dirty="0"/>
+            <a:endParaRPr lang="en-US" sz="3600" dirty="0"/>
           </a:p>
         </p:txBody>
       </p:sp>
@@ -1688,7 +1688,7 @@
         </p:nvSpPr>
         <p:spPr>
           <a:xfrm>
-            <a:off x="1103122" y="3547872"/>
+            <a:off x="1202182" y="3547872"/>
             <a:ext cx="0" cy="1386840"/>
           </a:xfrm>
           <a:prstGeom prst="line">
@@ -1711,7 +1711,7 @@
         </p:nvSpPr>
         <p:spPr>
           <a:xfrm>
-            <a:off x="11094974" y="3547872"/>
+            <a:off x="10995914" y="3547872"/>
             <a:ext cx="0" cy="1386840"/>
           </a:xfrm>
           <a:prstGeom prst="line">
@@ -1734,8 +1734,8 @@
         </p:nvSpPr>
         <p:spPr>
           <a:xfrm>
-            <a:off x="11227054" y="4010152"/>
-            <a:ext cx="792480" cy="462280"/>
+            <a:off x="11094974" y="3921252"/>
+            <a:ext cx="1097280" cy="640080"/>
           </a:xfrm>
           <a:prstGeom prst="rect">
             <a:avLst/>
@@ -1751,9 +1751,9 @@
               <a:buNone/>
             </a:pPr>
             <a:r>
-              <a:rPr lang="en-US" sz="2600" b="1" dirty="0">
+              <a:rPr lang="en-US" sz="3600" b="1" dirty="0">
                 <a:solidFill>
-                  <a:srgbClr val="8A8A8A"/>
+                  <a:srgbClr val="BBBBBB"/>
                 </a:solidFill>
                 <a:latin typeface="Arial" pitchFamily="34" charset="0"/>
                 <a:ea typeface="Arial" pitchFamily="34" charset="-122"/>
@@ -1761,7 +1761,7 @@
               </a:rPr>
               <a:t>×2</a:t>
             </a:r>
-            <a:endParaRPr lang="en-US" sz="2600" dirty="0"/>
+            <a:endParaRPr lang="en-US" sz="3600" dirty="0"/>
           </a:p>
         </p:txBody>
       </p:sp>
@@ -1947,7 +1947,7 @@
         </p:nvSpPr>
         <p:spPr>
           <a:xfrm>
-            <a:off x="1944472" y="2755392"/>
+            <a:off x="2043532" y="2755392"/>
             <a:ext cx="0" cy="2971800"/>
           </a:xfrm>
           <a:prstGeom prst="line">
@@ -1970,7 +1970,7 @@
         </p:nvSpPr>
         <p:spPr>
           <a:xfrm>
-            <a:off x="10253624" y="2755392"/>
+            <a:off x="10154564" y="2755392"/>
             <a:ext cx="0" cy="2971800"/>
           </a:xfrm>
           <a:prstGeom prst="line">
@@ -1993,8 +1993,8 @@
         </p:nvSpPr>
         <p:spPr>
           <a:xfrm>
-            <a:off x="10385704" y="4010152"/>
-            <a:ext cx="792480" cy="462280"/>
+            <a:off x="10253624" y="3921252"/>
+            <a:ext cx="1097280" cy="640080"/>
           </a:xfrm>
           <a:prstGeom prst="rect">
             <a:avLst/>
@@ -2010,9 +2010,9 @@
               <a:buNone/>
             </a:pPr>
             <a:r>
-              <a:rPr lang="en-US" sz="2600" b="1" dirty="0">
+              <a:rPr lang="en-US" sz="3600" b="1" dirty="0">
                 <a:solidFill>
-                  <a:srgbClr val="8A8A8A"/>
+                  <a:srgbClr val="BBBBBB"/>
                 </a:solidFill>
                 <a:latin typeface="Arial" pitchFamily="34" charset="0"/>
                 <a:ea typeface="Arial" pitchFamily="34" charset="-122"/>
@@ -2020,7 +2020,7 @@
               </a:rPr>
               <a:t>×2</a:t>
             </a:r>
-            <a:endParaRPr lang="en-US" sz="2600" dirty="0"/>
+            <a:endParaRPr lang="en-US" sz="3600" dirty="0"/>
           </a:p>
         </p:txBody>
       </p:sp>

</xml_diff>